<commit_message>
Stage 8 review fixes: HO-001
</commit_message>
<xml_diff>
--- a/output/archive/Tarnovell_Group/Brand/Launch/2020/Tarnovell_Group_Brand_Launch_2020-02.pptx
+++ b/output/archive/Tarnovell_Group/Brand/Launch/2020/Tarnovell_Group_Brand_Launch_2020-02.pptx
@@ -3960,7 +3960,7 @@
               <a:rPr sz="1800">
                 <a:latin typeface="Arial"/>
               </a:rPr>
-              <a:t>Common group master template for proposals, reports and presentations from 1 March 2020</a:t>
+              <a:t>Common group master template for proposals, reports and presentations under the 2020 launch</a:t>
             </a:r>
           </a:p>
           <a:p>
@@ -4771,7 +4771,7 @@
               <a:rPr sz="2000">
                 <a:latin typeface="Arial"/>
               </a:rPr>
-              <a:t>The group does not set local protocols, assay methods or reporting formats</a:t>
+              <a:t>Local scientific protocols and assay methods remain with each firm; presentation follows the common group master</a:t>
             </a:r>
           </a:p>
           <a:p>
@@ -4949,7 +4949,7 @@
               <a:rPr sz="2000">
                 <a:latin typeface="Arial"/>
               </a:rPr>
-              <a:t>Records created before 1 March 2020 are not being restyled to the new template</a:t>
+              <a:t>Records created before the 2020 group-template launch are not being restyled to the new template</a:t>
             </a:r>
           </a:p>
           <a:p>
@@ -5145,7 +5145,7 @@
               <a:rPr sz="2000">
                 <a:latin typeface="Arial"/>
               </a:rPr>
-              <a:t>Early March 2020: new template switched on for proposals and client-facing reports</a:t>
+              <a:t>February 2020: confirm local adoption of the group master introduced with the 2020 identity</a:t>
             </a:r>
           </a:p>
           <a:p>
@@ -5350,7 +5350,7 @@
               <a:rPr sz="2000">
                 <a:latin typeface="Arial"/>
               </a:rPr>
-              <a:t>Keep client communications on the current wording until the launch date is confirmed</a:t>
+              <a:t>Use the Tarnovell identity for new group-era communications; raise local template exceptions with head office</a:t>
             </a:r>
           </a:p>
         </p:txBody>

</xml_diff>